<commit_message>
Deck v9: panel feedback on v8 answered from the record; answers file, "If asked" notes and one-line slide statements
Sixteen SpaceX panel items keyed to v8 slides answered in docs/presentation/PANEL_FEEDBACK_ANSWERS_20261026.md with evidence
tags and sources; the floor-area share for bead homing computed from the bead_reach model (45 % at 1 m home, 93 % at 1.5 m,
against 5 % / 17 % of the volume). Deck v9 notes carry every answer; slides 4, 10, 12, 13, 15 and 24 carry one-line versions.
Five items the record lacks (friction source, fin paint, 3.3 V fault discovery, claw infill, hours/mentors) are questions
for Jasper with [[...]] placeholders. Rebuilt, validated, contact sheets regenerated.

Co-Authored-By: Claude Fable 5.1 <noreply@anthropic.com>
Claude-Session: https://claude.ai/code/session_012vxDhJBdXDDzxaEvKJXH5D
</commit_message>
<xml_diff>
--- a/docs/presentation/deck_v9/RoomCleaner_Buntinx_v9_appendix.pptx
+++ b/docs/presentation/deck_v9/RoomCleaner_Buntinx_v9_appendix.pptx
@@ -119,7 +119,7 @@
   <p:extLst>
     <p:ext uri="{521415D9-36F7-43E2-AB2F-B90AF26B5E84}">
       <p14:sectionLst xmlns:p14="http://schemas.microsoft.com/office/powerpoint/2010/main">
-        <p14:section name="Appendix" id="{c280a8e4-be7a-bdf0-aab8-0140ce050b24}">
+        <p14:section name="Appendix" id="{ebfc2e5b-9ca7-a76c-db2f-fabba853d1e2}">
           <p14:sldIdLst>
             <p14:sldId id="256"/>
             <p14:sldId id="257"/>
@@ -1508,7 +1508,7 @@
           <a:p>
             <a:r>
               <a:rPr lang="en-US" dirty="0"/>
-              <a:t>The gear pockets: the bearing presses past a lip, the T-slots let the lip ends flex, and it then sits free in a pocket 0.075 mm larger. The slide-in runs on 0.175 mm a side. The fin's sheared edges are only good to half a millimetre, so they locate only the first hole; the rest are drilled from it. [[confirm which spool bore is printed, which holes get heat-set inserts, and the insert part number]]</a:t>
+              <a:t>The gear pockets: the bearing presses past a lip, the T-slots let the lip ends flex, and it then sits free in a pocket 0.075 mm larger. The slide-in runs on 0.175 mm a side. The fin's sheared edges are only good to half a millimetre, so they locate only the first hole; the rest are drilled from it. [[confirm which spool bore is printed, which holes get heat-set inserts, and the insert part number]] If asked which feature each fit belongs to, row by row: gear bearings are the 687 ball bearings in the claw's gear housing, a Ø14.075 pocket behind a Ø14.000 entry lip with eight T-slots so the lip flexes as the bearing snaps past. Gear pins are the printed Ø7 pins the claw gears turn on, into Ø7.05 sockets. Slide-in mount is the station housing's dovetail ribs in the wall-mount grooves, 0.175 mm a side on 30° flanks. Spool on the D-shaft is the winch spool's bore on the motor's 5 mm D-flat shaft, Ø5.45 after Ø5.2 printed too tight. End-stop switch is the homing switch pressed into a pocket in the station slide-in. Heat-set inserts: M3 in the claw gear housing, M2.5 at the station encoder board. Screw clearance: M3 holes in the printed parts and the drilled fin, and the #6 wall-screw holes in the wall mount. Motor pilot is the NEMA 17's Ø22 boss through the printed motor tab and the drilled fin. Fin hole zero is the datum scheme for drilling the fin: the first hole from the sheared edges, the other four from it. All measured from my parts' CAD files and my fin method.</a:t>
             </a:r>
             <a:endParaRPr lang="en-US" dirty="0"/>
           </a:p>

</xml_diff>

<commit_message>
Deck v9.3: every panel item on a slide; per-Act recap lines; deliverable stated up front
Co-Authored-By: Claude Fable 5.1 <noreply@anthropic.com>
Claude-Session: https://claude.ai/code/session_012vxDhJBdXDDzxaEvKJXH5D
</commit_message>
<xml_diff>
--- a/docs/presentation/deck_v9/RoomCleaner_Buntinx_v9_appendix.pptx
+++ b/docs/presentation/deck_v9/RoomCleaner_Buntinx_v9_appendix.pptx
@@ -119,7 +119,7 @@
   <p:extLst>
     <p:ext uri="{521415D9-36F7-43E2-AB2F-B90AF26B5E84}">
       <p14:sectionLst xmlns:p14="http://schemas.microsoft.com/office/powerpoint/2010/main">
-        <p14:section name="Appendix" id="{c057cf7b-6dd1-5b4d-7497-6be9a7c8d161}">
+        <p14:section name="Appendix" id="{271709d4-f302-8eef-0395-96a49af6053f}">
           <p14:sldIdLst>
             <p14:sldId id="256"/>
             <p14:sldId id="257"/>
@@ -11505,11 +11505,12 @@
             <a:tbl>
               <a:tblPr/>
               <a:tblGrid>
-                <a:gridCol w="1287704"/>
-                <a:gridCol w="2266359"/>
-                <a:gridCol w="1596753"/>
+                <a:gridCol w="1030163"/>
+                <a:gridCol w="1030163"/>
+                <a:gridCol w="1854293"/>
+                <a:gridCol w="1236196"/>
               </a:tblGrid>
-              <a:tr h="402336">
+              <a:tr h="365760">
                 <a:tc>
                   <a:txBody>
                     <a:bodyPr/>
@@ -11519,7 +11520,7 @@
                         <a:buNone/>
                       </a:pPr>
                       <a:r>
-                        <a:rPr lang="en-US" sz="1050" b="1" dirty="0">
+                        <a:rPr lang="en-US" sz="900" b="1" dirty="0">
                           <a:solidFill>
                             <a:srgbClr val="FFFFFF"/>
                           </a:solidFill>
@@ -11529,7 +11530,7 @@
                         </a:rPr>
                         <a:t>Feature</a:t>
                       </a:r>
-                      <a:endParaRPr lang="en-US" sz="1050" dirty="0">
+                      <a:endParaRPr lang="en-US" sz="900" dirty="0">
                         <a:latin typeface="Arial" charset="0"/>
                         <a:ea typeface="Arial" charset="0"/>
                         <a:cs typeface="Arial" charset="0"/>
@@ -11587,7 +11588,7 @@
                         <a:buNone/>
                       </a:pPr>
                       <a:r>
-                        <a:rPr lang="en-US" sz="1050" b="1" dirty="0">
+                        <a:rPr lang="en-US" sz="900" b="1" dirty="0">
                           <a:solidFill>
                             <a:srgbClr val="FFFFFF"/>
                           </a:solidFill>
@@ -11595,9 +11596,9 @@
                           <a:ea typeface="Arial" pitchFamily="34" charset="-122"/>
                           <a:cs typeface="Arial" pitchFamily="34" charset="-120"/>
                         </a:rPr>
-                        <a:t>As drawn</a:t>
+                        <a:t>Part</a:t>
                       </a:r>
-                      <a:endParaRPr lang="en-US" sz="1050" dirty="0">
+                      <a:endParaRPr lang="en-US" sz="900" dirty="0">
                         <a:latin typeface="Arial" charset="0"/>
                         <a:ea typeface="Arial" charset="0"/>
                         <a:cs typeface="Arial" charset="0"/>
@@ -11655,7 +11656,75 @@
                         <a:buNone/>
                       </a:pPr>
                       <a:r>
-                        <a:rPr lang="en-US" sz="1050" b="1" dirty="0">
+                        <a:rPr lang="en-US" sz="900" b="1" dirty="0">
+                          <a:solidFill>
+                            <a:srgbClr val="FFFFFF"/>
+                          </a:solidFill>
+                          <a:latin typeface="Arial" pitchFamily="34" charset="0"/>
+                          <a:ea typeface="Arial" pitchFamily="34" charset="-122"/>
+                          <a:cs typeface="Arial" pitchFamily="34" charset="-120"/>
+                        </a:rPr>
+                        <a:t>As drawn</a:t>
+                      </a:r>
+                      <a:endParaRPr lang="en-US" sz="900" dirty="0">
+                        <a:latin typeface="Arial" charset="0"/>
+                        <a:ea typeface="Arial" charset="0"/>
+                        <a:cs typeface="Arial" charset="0"/>
+                      </a:endParaRPr>
+                    </a:p>
+                  </a:txBody>
+                  <a:tcPr marL="54864" marR="54864" marT="54864" marB="54864" anchor="ctr">
+                    <a:lnL w="9525" cap="flat" cmpd="sng" algn="ctr">
+                      <a:solidFill>
+                        <a:srgbClr val="BFBFBF"/>
+                      </a:solidFill>
+                      <a:prstDash val="solid"/>
+                      <a:round/>
+                      <a:headEnd type="none" w="med" len="med"/>
+                      <a:tailEnd type="none" w="med" len="med"/>
+                    </a:lnL>
+                    <a:lnR w="9525" cap="flat" cmpd="sng" algn="ctr">
+                      <a:solidFill>
+                        <a:srgbClr val="BFBFBF"/>
+                      </a:solidFill>
+                      <a:prstDash val="solid"/>
+                      <a:round/>
+                      <a:headEnd type="none" w="med" len="med"/>
+                      <a:tailEnd type="none" w="med" len="med"/>
+                    </a:lnR>
+                    <a:lnT w="9525" cap="flat" cmpd="sng" algn="ctr">
+                      <a:solidFill>
+                        <a:srgbClr val="BFBFBF"/>
+                      </a:solidFill>
+                      <a:prstDash val="solid"/>
+                      <a:round/>
+                      <a:headEnd type="none" w="med" len="med"/>
+                      <a:tailEnd type="none" w="med" len="med"/>
+                    </a:lnT>
+                    <a:lnB w="9525" cap="flat" cmpd="sng" algn="ctr">
+                      <a:solidFill>
+                        <a:srgbClr val="BFBFBF"/>
+                      </a:solidFill>
+                      <a:prstDash val="solid"/>
+                      <a:round/>
+                      <a:headEnd type="none" w="med" len="med"/>
+                      <a:tailEnd type="none" w="med" len="med"/>
+                    </a:lnB>
+                    <a:solidFill>
+                      <a:srgbClr val="1F3A5F"/>
+                    </a:solidFill>
+                  </a:tcPr>
+                </a:tc>
+                <a:tc>
+                  <a:txBody>
+                    <a:bodyPr/>
+                    <a:lstStyle/>
+                    <a:p>
+                      <a:pPr indent="0" marL="0">
+                        <a:buNone/>
+                      </a:pPr>
+                      <a:r>
+                        <a:rPr lang="en-US" sz="900" b="1" dirty="0">
                           <a:solidFill>
                             <a:srgbClr val="FFFFFF"/>
                           </a:solidFill>
@@ -11665,7 +11734,7 @@
                         </a:rPr>
                         <a:t>Fit</a:t>
                       </a:r>
-                      <a:endParaRPr lang="en-US" sz="1050" dirty="0">
+                      <a:endParaRPr lang="en-US" sz="900" dirty="0">
                         <a:latin typeface="Arial" charset="0"/>
                         <a:ea typeface="Arial" charset="0"/>
                         <a:cs typeface="Arial" charset="0"/>
@@ -11715,7 +11784,7 @@
                   </a:tcPr>
                 </a:tc>
               </a:tr>
-              <a:tr h="402336">
+              <a:tr h="365760">
                 <a:tc>
                   <a:txBody>
                     <a:bodyPr/>
@@ -11725,7 +11794,7 @@
                         <a:buNone/>
                       </a:pPr>
                       <a:r>
-                        <a:rPr lang="en-US" sz="1050" b="1" dirty="0">
+                        <a:rPr lang="en-US" sz="900" b="1" dirty="0">
                           <a:solidFill>
                             <a:srgbClr val="1A1A1A"/>
                           </a:solidFill>
@@ -11735,7 +11804,7 @@
                         </a:rPr>
                         <a:t>Gear bearings (687)</a:t>
                       </a:r>
-                      <a:endParaRPr lang="en-US" sz="1050" dirty="0">
+                      <a:endParaRPr lang="en-US" sz="900" dirty="0">
                         <a:latin typeface="Arial" charset="0"/>
                         <a:ea typeface="Arial" charset="0"/>
                         <a:cs typeface="Arial" charset="0"/>
@@ -11790,7 +11859,7 @@
                         <a:buNone/>
                       </a:pPr>
                       <a:r>
-                        <a:rPr lang="en-US" sz="1050" dirty="0">
+                        <a:rPr lang="en-US" sz="900" dirty="0">
                           <a:solidFill>
                             <a:srgbClr val="1A1A1A"/>
                           </a:solidFill>
@@ -11798,9 +11867,9 @@
                           <a:ea typeface="Arial" pitchFamily="34" charset="-122"/>
                           <a:cs typeface="Arial" pitchFamily="34" charset="-120"/>
                         </a:rPr>
-                        <a:t>Ø14.075 pocket behind a Ø14.000 lip, 1.95 long, 8 T-slots</a:t>
+                        <a:t>Claw gear housing</a:t>
                       </a:r>
-                      <a:endParaRPr lang="en-US" sz="1050" dirty="0">
+                      <a:endParaRPr lang="en-US" sz="900" dirty="0">
                         <a:latin typeface="Arial" charset="0"/>
                         <a:ea typeface="Arial" charset="0"/>
                         <a:cs typeface="Arial" charset="0"/>
@@ -11855,7 +11924,7 @@
                         <a:buNone/>
                       </a:pPr>
                       <a:r>
-                        <a:rPr lang="en-US" sz="1050" dirty="0">
+                        <a:rPr lang="en-US" sz="900" dirty="0">
                           <a:solidFill>
                             <a:srgbClr val="1A1A1A"/>
                           </a:solidFill>
@@ -11863,76 +11932,9 @@
                           <a:ea typeface="Arial" pitchFamily="34" charset="-122"/>
                           <a:cs typeface="Arial" pitchFamily="34" charset="-120"/>
                         </a:rPr>
-                        <a:t>Snaps past the lip, +0.075 behind it</a:t>
+                        <a:t>Ø14.075 pocket behind a Ø14.000 lip, 1.95 long, 8 T-slots</a:t>
                       </a:r>
-                      <a:endParaRPr lang="en-US" sz="1050" dirty="0">
-                        <a:latin typeface="Arial" charset="0"/>
-                        <a:ea typeface="Arial" charset="0"/>
-                        <a:cs typeface="Arial" charset="0"/>
-                      </a:endParaRPr>
-                    </a:p>
-                  </a:txBody>
-                  <a:tcPr marL="54864" marR="54864" marT="54864" marB="54864" anchor="ctr">
-                    <a:lnL w="9525" cap="flat" cmpd="sng" algn="ctr">
-                      <a:solidFill>
-                        <a:srgbClr val="BFBFBF"/>
-                      </a:solidFill>
-                      <a:prstDash val="solid"/>
-                      <a:round/>
-                      <a:headEnd type="none" w="med" len="med"/>
-                      <a:tailEnd type="none" w="med" len="med"/>
-                    </a:lnL>
-                    <a:lnR w="9525" cap="flat" cmpd="sng" algn="ctr">
-                      <a:solidFill>
-                        <a:srgbClr val="BFBFBF"/>
-                      </a:solidFill>
-                      <a:prstDash val="solid"/>
-                      <a:round/>
-                      <a:headEnd type="none" w="med" len="med"/>
-                      <a:tailEnd type="none" w="med" len="med"/>
-                    </a:lnR>
-                    <a:lnT w="9525" cap="flat" cmpd="sng" algn="ctr">
-                      <a:solidFill>
-                        <a:srgbClr val="BFBFBF"/>
-                      </a:solidFill>
-                      <a:prstDash val="solid"/>
-                      <a:round/>
-                      <a:headEnd type="none" w="med" len="med"/>
-                      <a:tailEnd type="none" w="med" len="med"/>
-                    </a:lnT>
-                    <a:lnB w="9525" cap="flat" cmpd="sng" algn="ctr">
-                      <a:solidFill>
-                        <a:srgbClr val="BFBFBF"/>
-                      </a:solidFill>
-                      <a:prstDash val="solid"/>
-                      <a:round/>
-                      <a:headEnd type="none" w="med" len="med"/>
-                      <a:tailEnd type="none" w="med" len="med"/>
-                    </a:lnB>
-                  </a:tcPr>
-                </a:tc>
-              </a:tr>
-              <a:tr h="402336">
-                <a:tc>
-                  <a:txBody>
-                    <a:bodyPr/>
-                    <a:lstStyle/>
-                    <a:p>
-                      <a:pPr indent="0" marL="0">
-                        <a:buNone/>
-                      </a:pPr>
-                      <a:r>
-                        <a:rPr lang="en-US" sz="1050" b="1" dirty="0">
-                          <a:solidFill>
-                            <a:srgbClr val="1A1A1A"/>
-                          </a:solidFill>
-                          <a:latin typeface="Arial" pitchFamily="34" charset="0"/>
-                          <a:ea typeface="Arial" pitchFamily="34" charset="-122"/>
-                          <a:cs typeface="Arial" pitchFamily="34" charset="-120"/>
-                        </a:rPr>
-                        <a:t>Gear pins</a:t>
-                      </a:r>
-                      <a:endParaRPr lang="en-US" sz="1050" dirty="0">
+                      <a:endParaRPr lang="en-US" sz="900" dirty="0">
                         <a:latin typeface="Arial" charset="0"/>
                         <a:ea typeface="Arial" charset="0"/>
                         <a:cs typeface="Arial" charset="0"/>
@@ -11987,7 +11989,7 @@
                         <a:buNone/>
                       </a:pPr>
                       <a:r>
-                        <a:rPr lang="en-US" sz="1050" dirty="0">
+                        <a:rPr lang="en-US" sz="900" dirty="0">
                           <a:solidFill>
                             <a:srgbClr val="1A1A1A"/>
                           </a:solidFill>
@@ -11995,9 +11997,76 @@
                           <a:ea typeface="Arial" pitchFamily="34" charset="-122"/>
                           <a:cs typeface="Arial" pitchFamily="34" charset="-120"/>
                         </a:rPr>
-                        <a:t>Printed Ø7.000 pin into a Ø7.05 socket</a:t>
+                        <a:t>Snaps past the lip, +0.075 behind it</a:t>
                       </a:r>
-                      <a:endParaRPr lang="en-US" sz="1050" dirty="0">
+                      <a:endParaRPr lang="en-US" sz="900" dirty="0">
+                        <a:latin typeface="Arial" charset="0"/>
+                        <a:ea typeface="Arial" charset="0"/>
+                        <a:cs typeface="Arial" charset="0"/>
+                      </a:endParaRPr>
+                    </a:p>
+                  </a:txBody>
+                  <a:tcPr marL="54864" marR="54864" marT="54864" marB="54864" anchor="ctr">
+                    <a:lnL w="9525" cap="flat" cmpd="sng" algn="ctr">
+                      <a:solidFill>
+                        <a:srgbClr val="BFBFBF"/>
+                      </a:solidFill>
+                      <a:prstDash val="solid"/>
+                      <a:round/>
+                      <a:headEnd type="none" w="med" len="med"/>
+                      <a:tailEnd type="none" w="med" len="med"/>
+                    </a:lnL>
+                    <a:lnR w="9525" cap="flat" cmpd="sng" algn="ctr">
+                      <a:solidFill>
+                        <a:srgbClr val="BFBFBF"/>
+                      </a:solidFill>
+                      <a:prstDash val="solid"/>
+                      <a:round/>
+                      <a:headEnd type="none" w="med" len="med"/>
+                      <a:tailEnd type="none" w="med" len="med"/>
+                    </a:lnR>
+                    <a:lnT w="9525" cap="flat" cmpd="sng" algn="ctr">
+                      <a:solidFill>
+                        <a:srgbClr val="BFBFBF"/>
+                      </a:solidFill>
+                      <a:prstDash val="solid"/>
+                      <a:round/>
+                      <a:headEnd type="none" w="med" len="med"/>
+                      <a:tailEnd type="none" w="med" len="med"/>
+                    </a:lnT>
+                    <a:lnB w="9525" cap="flat" cmpd="sng" algn="ctr">
+                      <a:solidFill>
+                        <a:srgbClr val="BFBFBF"/>
+                      </a:solidFill>
+                      <a:prstDash val="solid"/>
+                      <a:round/>
+                      <a:headEnd type="none" w="med" len="med"/>
+                      <a:tailEnd type="none" w="med" len="med"/>
+                    </a:lnB>
+                  </a:tcPr>
+                </a:tc>
+              </a:tr>
+              <a:tr h="365760">
+                <a:tc>
+                  <a:txBody>
+                    <a:bodyPr/>
+                    <a:lstStyle/>
+                    <a:p>
+                      <a:pPr indent="0" marL="0">
+                        <a:buNone/>
+                      </a:pPr>
+                      <a:r>
+                        <a:rPr lang="en-US" sz="900" b="1" dirty="0">
+                          <a:solidFill>
+                            <a:srgbClr val="1A1A1A"/>
+                          </a:solidFill>
+                          <a:latin typeface="Arial" pitchFamily="34" charset="0"/>
+                          <a:ea typeface="Arial" pitchFamily="34" charset="-122"/>
+                          <a:cs typeface="Arial" pitchFamily="34" charset="-120"/>
+                        </a:rPr>
+                        <a:t>Gear pins</a:t>
+                      </a:r>
+                      <a:endParaRPr lang="en-US" sz="900" dirty="0">
                         <a:latin typeface="Arial" charset="0"/>
                         <a:ea typeface="Arial" charset="0"/>
                         <a:cs typeface="Arial" charset="0"/>
@@ -12052,7 +12121,7 @@
                         <a:buNone/>
                       </a:pPr>
                       <a:r>
-                        <a:rPr lang="en-US" sz="1050" dirty="0">
+                        <a:rPr lang="en-US" sz="900" dirty="0">
                           <a:solidFill>
                             <a:srgbClr val="1A1A1A"/>
                           </a:solidFill>
@@ -12060,76 +12129,9 @@
                           <a:ea typeface="Arial" pitchFamily="34" charset="-122"/>
                           <a:cs typeface="Arial" pitchFamily="34" charset="-120"/>
                         </a:rPr>
-                        <a:t>Line-to-line in the bearing; +0.05</a:t>
+                        <a:t>Claw gear housing</a:t>
                       </a:r>
-                      <a:endParaRPr lang="en-US" sz="1050" dirty="0">
-                        <a:latin typeface="Arial" charset="0"/>
-                        <a:ea typeface="Arial" charset="0"/>
-                        <a:cs typeface="Arial" charset="0"/>
-                      </a:endParaRPr>
-                    </a:p>
-                  </a:txBody>
-                  <a:tcPr marL="54864" marR="54864" marT="54864" marB="54864" anchor="ctr">
-                    <a:lnL w="9525" cap="flat" cmpd="sng" algn="ctr">
-                      <a:solidFill>
-                        <a:srgbClr val="BFBFBF"/>
-                      </a:solidFill>
-                      <a:prstDash val="solid"/>
-                      <a:round/>
-                      <a:headEnd type="none" w="med" len="med"/>
-                      <a:tailEnd type="none" w="med" len="med"/>
-                    </a:lnL>
-                    <a:lnR w="9525" cap="flat" cmpd="sng" algn="ctr">
-                      <a:solidFill>
-                        <a:srgbClr val="BFBFBF"/>
-                      </a:solidFill>
-                      <a:prstDash val="solid"/>
-                      <a:round/>
-                      <a:headEnd type="none" w="med" len="med"/>
-                      <a:tailEnd type="none" w="med" len="med"/>
-                    </a:lnR>
-                    <a:lnT w="9525" cap="flat" cmpd="sng" algn="ctr">
-                      <a:solidFill>
-                        <a:srgbClr val="BFBFBF"/>
-                      </a:solidFill>
-                      <a:prstDash val="solid"/>
-                      <a:round/>
-                      <a:headEnd type="none" w="med" len="med"/>
-                      <a:tailEnd type="none" w="med" len="med"/>
-                    </a:lnT>
-                    <a:lnB w="9525" cap="flat" cmpd="sng" algn="ctr">
-                      <a:solidFill>
-                        <a:srgbClr val="BFBFBF"/>
-                      </a:solidFill>
-                      <a:prstDash val="solid"/>
-                      <a:round/>
-                      <a:headEnd type="none" w="med" len="med"/>
-                      <a:tailEnd type="none" w="med" len="med"/>
-                    </a:lnB>
-                  </a:tcPr>
-                </a:tc>
-              </a:tr>
-              <a:tr h="402336">
-                <a:tc>
-                  <a:txBody>
-                    <a:bodyPr/>
-                    <a:lstStyle/>
-                    <a:p>
-                      <a:pPr indent="0" marL="0">
-                        <a:buNone/>
-                      </a:pPr>
-                      <a:r>
-                        <a:rPr lang="en-US" sz="1050" b="1" dirty="0">
-                          <a:solidFill>
-                            <a:srgbClr val="1A1A1A"/>
-                          </a:solidFill>
-                          <a:latin typeface="Arial" pitchFamily="34" charset="0"/>
-                          <a:ea typeface="Arial" pitchFamily="34" charset="-122"/>
-                          <a:cs typeface="Arial" pitchFamily="34" charset="-120"/>
-                        </a:rPr>
-                        <a:t>Slide-in mount</a:t>
-                      </a:r>
-                      <a:endParaRPr lang="en-US" sz="1050" dirty="0">
+                      <a:endParaRPr lang="en-US" sz="900" dirty="0">
                         <a:latin typeface="Arial" charset="0"/>
                         <a:ea typeface="Arial" charset="0"/>
                         <a:cs typeface="Arial" charset="0"/>
@@ -12184,7 +12186,7 @@
                         <a:buNone/>
                       </a:pPr>
                       <a:r>
-                        <a:rPr lang="en-US" sz="1050" dirty="0">
+                        <a:rPr lang="en-US" sz="900" dirty="0">
                           <a:solidFill>
                             <a:srgbClr val="1A1A1A"/>
                           </a:solidFill>
@@ -12192,9 +12194,9 @@
                           <a:ea typeface="Arial" pitchFamily="34" charset="-122"/>
                           <a:cs typeface="Arial" pitchFamily="34" charset="-120"/>
                         </a:rPr>
-                        <a:t>0.175 per side; 30° dovetail flanks</a:t>
+                        <a:t>Printed Ø7.000 pin into a Ø7.05 socket</a:t>
                       </a:r>
-                      <a:endParaRPr lang="en-US" sz="1050" dirty="0">
+                      <a:endParaRPr lang="en-US" sz="900" dirty="0">
                         <a:latin typeface="Arial" charset="0"/>
                         <a:ea typeface="Arial" charset="0"/>
                         <a:cs typeface="Arial" charset="0"/>
@@ -12249,7 +12251,7 @@
                         <a:buNone/>
                       </a:pPr>
                       <a:r>
-                        <a:rPr lang="en-US" sz="1050" dirty="0">
+                        <a:rPr lang="en-US" sz="900" dirty="0">
                           <a:solidFill>
                             <a:srgbClr val="1A1A1A"/>
                           </a:solidFill>
@@ -12257,9 +12259,9 @@
                           <a:ea typeface="Arial" pitchFamily="34" charset="-122"/>
                           <a:cs typeface="Arial" pitchFamily="34" charset="-120"/>
                         </a:rPr>
-                        <a:t>Slip fit, 0.14–0.21 on the flanks</a:t>
+                        <a:t>Line-to-line in the bearing; +0.05</a:t>
                       </a:r>
-                      <a:endParaRPr lang="en-US" sz="1050" dirty="0">
+                      <a:endParaRPr lang="en-US" sz="900" dirty="0">
                         <a:latin typeface="Arial" charset="0"/>
                         <a:ea typeface="Arial" charset="0"/>
                         <a:cs typeface="Arial" charset="0"/>
@@ -12306,7 +12308,7 @@
                   </a:tcPr>
                 </a:tc>
               </a:tr>
-              <a:tr h="402336">
+              <a:tr h="365760">
                 <a:tc>
                   <a:txBody>
                     <a:bodyPr/>
@@ -12316,7 +12318,7 @@
                         <a:buNone/>
                       </a:pPr>
                       <a:r>
-                        <a:rPr lang="en-US" sz="1050" b="1" dirty="0">
+                        <a:rPr lang="en-US" sz="900" b="1" dirty="0">
                           <a:solidFill>
                             <a:srgbClr val="1A1A1A"/>
                           </a:solidFill>
@@ -12324,9 +12326,9 @@
                           <a:ea typeface="Arial" pitchFamily="34" charset="-122"/>
                           <a:cs typeface="Arial" pitchFamily="34" charset="-120"/>
                         </a:rPr>
-                        <a:t>Spool on Ø5 D-shaft</a:t>
+                        <a:t>Slide-in mount</a:t>
                       </a:r>
-                      <a:endParaRPr lang="en-US" sz="1050" dirty="0">
+                      <a:endParaRPr lang="en-US" sz="900" dirty="0">
                         <a:latin typeface="Arial" charset="0"/>
                         <a:ea typeface="Arial" charset="0"/>
                         <a:cs typeface="Arial" charset="0"/>
@@ -12381,7 +12383,7 @@
                         <a:buNone/>
                       </a:pPr>
                       <a:r>
-                        <a:rPr lang="en-US" sz="1050" dirty="0">
+                        <a:rPr lang="en-US" sz="900" dirty="0">
                           <a:solidFill>
                             <a:srgbClr val="1A1A1A"/>
                           </a:solidFill>
@@ -12389,9 +12391,9 @@
                           <a:ea typeface="Arial" pitchFamily="34" charset="-122"/>
                           <a:cs typeface="Arial" pitchFamily="34" charset="-120"/>
                         </a:rPr>
-                        <a:t>Ø5.30 bore (10/21), Ø5.45 in v3; 0.5 mm flat</a:t>
+                        <a:t>Station housing in the wall mount</a:t>
                       </a:r>
-                      <a:endParaRPr lang="en-US" sz="1050" dirty="0">
+                      <a:endParaRPr lang="en-US" sz="900" dirty="0">
                         <a:latin typeface="Arial" charset="0"/>
                         <a:ea typeface="Arial" charset="0"/>
                         <a:cs typeface="Arial" charset="0"/>
@@ -12446,7 +12448,7 @@
                         <a:buNone/>
                       </a:pPr>
                       <a:r>
-                        <a:rPr lang="en-US" sz="1050" dirty="0">
+                        <a:rPr lang="en-US" sz="900" dirty="0">
                           <a:solidFill>
                             <a:srgbClr val="1A1A1A"/>
                           </a:solidFill>
@@ -12454,76 +12456,9 @@
                           <a:ea typeface="Arial" pitchFamily="34" charset="-122"/>
                           <a:cs typeface="Arial" pitchFamily="34" charset="-120"/>
                         </a:rPr>
-                        <a:t>+0.30 to +0.45: Ø5.2 printed too tight</a:t>
+                        <a:t>0.175 per side; 30° dovetail flanks</a:t>
                       </a:r>
-                      <a:endParaRPr lang="en-US" sz="1050" dirty="0">
-                        <a:latin typeface="Arial" charset="0"/>
-                        <a:ea typeface="Arial" charset="0"/>
-                        <a:cs typeface="Arial" charset="0"/>
-                      </a:endParaRPr>
-                    </a:p>
-                  </a:txBody>
-                  <a:tcPr marL="54864" marR="54864" marT="54864" marB="54864" anchor="ctr">
-                    <a:lnL w="9525" cap="flat" cmpd="sng" algn="ctr">
-                      <a:solidFill>
-                        <a:srgbClr val="BFBFBF"/>
-                      </a:solidFill>
-                      <a:prstDash val="solid"/>
-                      <a:round/>
-                      <a:headEnd type="none" w="med" len="med"/>
-                      <a:tailEnd type="none" w="med" len="med"/>
-                    </a:lnL>
-                    <a:lnR w="9525" cap="flat" cmpd="sng" algn="ctr">
-                      <a:solidFill>
-                        <a:srgbClr val="BFBFBF"/>
-                      </a:solidFill>
-                      <a:prstDash val="solid"/>
-                      <a:round/>
-                      <a:headEnd type="none" w="med" len="med"/>
-                      <a:tailEnd type="none" w="med" len="med"/>
-                    </a:lnR>
-                    <a:lnT w="9525" cap="flat" cmpd="sng" algn="ctr">
-                      <a:solidFill>
-                        <a:srgbClr val="BFBFBF"/>
-                      </a:solidFill>
-                      <a:prstDash val="solid"/>
-                      <a:round/>
-                      <a:headEnd type="none" w="med" len="med"/>
-                      <a:tailEnd type="none" w="med" len="med"/>
-                    </a:lnT>
-                    <a:lnB w="9525" cap="flat" cmpd="sng" algn="ctr">
-                      <a:solidFill>
-                        <a:srgbClr val="BFBFBF"/>
-                      </a:solidFill>
-                      <a:prstDash val="solid"/>
-                      <a:round/>
-                      <a:headEnd type="none" w="med" len="med"/>
-                      <a:tailEnd type="none" w="med" len="med"/>
-                    </a:lnB>
-                  </a:tcPr>
-                </a:tc>
-              </a:tr>
-              <a:tr h="402336">
-                <a:tc>
-                  <a:txBody>
-                    <a:bodyPr/>
-                    <a:lstStyle/>
-                    <a:p>
-                      <a:pPr indent="0" marL="0">
-                        <a:buNone/>
-                      </a:pPr>
-                      <a:r>
-                        <a:rPr lang="en-US" sz="1050" b="1" dirty="0">
-                          <a:solidFill>
-                            <a:srgbClr val="1A1A1A"/>
-                          </a:solidFill>
-                          <a:latin typeface="Arial" pitchFamily="34" charset="0"/>
-                          <a:ea typeface="Arial" pitchFamily="34" charset="-122"/>
-                          <a:cs typeface="Arial" pitchFamily="34" charset="-120"/>
-                        </a:rPr>
-                        <a:t>End-stop switch</a:t>
-                      </a:r>
-                      <a:endParaRPr lang="en-US" sz="1050" dirty="0">
+                      <a:endParaRPr lang="en-US" sz="900" dirty="0">
                         <a:latin typeface="Arial" charset="0"/>
                         <a:ea typeface="Arial" charset="0"/>
                         <a:cs typeface="Arial" charset="0"/>
@@ -12578,7 +12513,7 @@
                         <a:buNone/>
                       </a:pPr>
                       <a:r>
-                        <a:rPr lang="en-US" sz="1050" dirty="0">
+                        <a:rPr lang="en-US" sz="900" dirty="0">
                           <a:solidFill>
                             <a:srgbClr val="1A1A1A"/>
                           </a:solidFill>
@@ -12586,9 +12521,76 @@
                           <a:ea typeface="Arial" pitchFamily="34" charset="-122"/>
                           <a:cs typeface="Arial" pitchFamily="34" charset="-120"/>
                         </a:rPr>
-                        <a:t>Pocket 6.65 × 20.3 × 9 on a 1 mm ledge, lever window below</a:t>
+                        <a:t>Slip fit, 0.14–0.21 on the flanks</a:t>
                       </a:r>
-                      <a:endParaRPr lang="en-US" sz="1050" dirty="0">
+                      <a:endParaRPr lang="en-US" sz="900" dirty="0">
+                        <a:latin typeface="Arial" charset="0"/>
+                        <a:ea typeface="Arial" charset="0"/>
+                        <a:cs typeface="Arial" charset="0"/>
+                      </a:endParaRPr>
+                    </a:p>
+                  </a:txBody>
+                  <a:tcPr marL="54864" marR="54864" marT="54864" marB="54864" anchor="ctr">
+                    <a:lnL w="9525" cap="flat" cmpd="sng" algn="ctr">
+                      <a:solidFill>
+                        <a:srgbClr val="BFBFBF"/>
+                      </a:solidFill>
+                      <a:prstDash val="solid"/>
+                      <a:round/>
+                      <a:headEnd type="none" w="med" len="med"/>
+                      <a:tailEnd type="none" w="med" len="med"/>
+                    </a:lnL>
+                    <a:lnR w="9525" cap="flat" cmpd="sng" algn="ctr">
+                      <a:solidFill>
+                        <a:srgbClr val="BFBFBF"/>
+                      </a:solidFill>
+                      <a:prstDash val="solid"/>
+                      <a:round/>
+                      <a:headEnd type="none" w="med" len="med"/>
+                      <a:tailEnd type="none" w="med" len="med"/>
+                    </a:lnR>
+                    <a:lnT w="9525" cap="flat" cmpd="sng" algn="ctr">
+                      <a:solidFill>
+                        <a:srgbClr val="BFBFBF"/>
+                      </a:solidFill>
+                      <a:prstDash val="solid"/>
+                      <a:round/>
+                      <a:headEnd type="none" w="med" len="med"/>
+                      <a:tailEnd type="none" w="med" len="med"/>
+                    </a:lnT>
+                    <a:lnB w="9525" cap="flat" cmpd="sng" algn="ctr">
+                      <a:solidFill>
+                        <a:srgbClr val="BFBFBF"/>
+                      </a:solidFill>
+                      <a:prstDash val="solid"/>
+                      <a:round/>
+                      <a:headEnd type="none" w="med" len="med"/>
+                      <a:tailEnd type="none" w="med" len="med"/>
+                    </a:lnB>
+                  </a:tcPr>
+                </a:tc>
+              </a:tr>
+              <a:tr h="365760">
+                <a:tc>
+                  <a:txBody>
+                    <a:bodyPr/>
+                    <a:lstStyle/>
+                    <a:p>
+                      <a:pPr indent="0" marL="0">
+                        <a:buNone/>
+                      </a:pPr>
+                      <a:r>
+                        <a:rPr lang="en-US" sz="900" b="1" dirty="0">
+                          <a:solidFill>
+                            <a:srgbClr val="1A1A1A"/>
+                          </a:solidFill>
+                          <a:latin typeface="Arial" pitchFamily="34" charset="0"/>
+                          <a:ea typeface="Arial" pitchFamily="34" charset="-122"/>
+                          <a:cs typeface="Arial" pitchFamily="34" charset="-120"/>
+                        </a:rPr>
+                        <a:t>Spool on Ø5 D-shaft</a:t>
+                      </a:r>
+                      <a:endParaRPr lang="en-US" sz="900" dirty="0">
                         <a:latin typeface="Arial" charset="0"/>
                         <a:ea typeface="Arial" charset="0"/>
                         <a:cs typeface="Arial" charset="0"/>
@@ -12643,7 +12645,7 @@
                         <a:buNone/>
                       </a:pPr>
                       <a:r>
-                        <a:rPr lang="en-US" sz="1050" dirty="0">
+                        <a:rPr lang="en-US" sz="900" dirty="0">
                           <a:solidFill>
                             <a:srgbClr val="1A1A1A"/>
                           </a:solidFill>
@@ -12651,76 +12653,9 @@
                           <a:ea typeface="Arial" pitchFamily="34" charset="-122"/>
                           <a:cs typeface="Arial" pitchFamily="34" charset="-120"/>
                         </a:rPr>
-                        <a:t>Press fit, no screws</a:t>
+                        <a:t>Winch spool on the motor shaft</a:t>
                       </a:r>
-                      <a:endParaRPr lang="en-US" sz="1050" dirty="0">
-                        <a:latin typeface="Arial" charset="0"/>
-                        <a:ea typeface="Arial" charset="0"/>
-                        <a:cs typeface="Arial" charset="0"/>
-                      </a:endParaRPr>
-                    </a:p>
-                  </a:txBody>
-                  <a:tcPr marL="54864" marR="54864" marT="54864" marB="54864" anchor="ctr">
-                    <a:lnL w="9525" cap="flat" cmpd="sng" algn="ctr">
-                      <a:solidFill>
-                        <a:srgbClr val="BFBFBF"/>
-                      </a:solidFill>
-                      <a:prstDash val="solid"/>
-                      <a:round/>
-                      <a:headEnd type="none" w="med" len="med"/>
-                      <a:tailEnd type="none" w="med" len="med"/>
-                    </a:lnL>
-                    <a:lnR w="9525" cap="flat" cmpd="sng" algn="ctr">
-                      <a:solidFill>
-                        <a:srgbClr val="BFBFBF"/>
-                      </a:solidFill>
-                      <a:prstDash val="solid"/>
-                      <a:round/>
-                      <a:headEnd type="none" w="med" len="med"/>
-                      <a:tailEnd type="none" w="med" len="med"/>
-                    </a:lnR>
-                    <a:lnT w="9525" cap="flat" cmpd="sng" algn="ctr">
-                      <a:solidFill>
-                        <a:srgbClr val="BFBFBF"/>
-                      </a:solidFill>
-                      <a:prstDash val="solid"/>
-                      <a:round/>
-                      <a:headEnd type="none" w="med" len="med"/>
-                      <a:tailEnd type="none" w="med" len="med"/>
-                    </a:lnT>
-                    <a:lnB w="9525" cap="flat" cmpd="sng" algn="ctr">
-                      <a:solidFill>
-                        <a:srgbClr val="BFBFBF"/>
-                      </a:solidFill>
-                      <a:prstDash val="solid"/>
-                      <a:round/>
-                      <a:headEnd type="none" w="med" len="med"/>
-                      <a:tailEnd type="none" w="med" len="med"/>
-                    </a:lnB>
-                  </a:tcPr>
-                </a:tc>
-              </a:tr>
-              <a:tr h="402336">
-                <a:tc>
-                  <a:txBody>
-                    <a:bodyPr/>
-                    <a:lstStyle/>
-                    <a:p>
-                      <a:pPr indent="0" marL="0">
-                        <a:buNone/>
-                      </a:pPr>
-                      <a:r>
-                        <a:rPr lang="en-US" sz="1050" b="1" dirty="0">
-                          <a:solidFill>
-                            <a:srgbClr val="1A1A1A"/>
-                          </a:solidFill>
-                          <a:latin typeface="Arial" pitchFamily="34" charset="0"/>
-                          <a:ea typeface="Arial" pitchFamily="34" charset="-122"/>
-                          <a:cs typeface="Arial" pitchFamily="34" charset="-120"/>
-                        </a:rPr>
-                        <a:t>Heat-set inserts</a:t>
-                      </a:r>
-                      <a:endParaRPr lang="en-US" sz="1050" dirty="0">
+                      <a:endParaRPr lang="en-US" sz="900" dirty="0">
                         <a:latin typeface="Arial" charset="0"/>
                         <a:ea typeface="Arial" charset="0"/>
                         <a:cs typeface="Arial" charset="0"/>
@@ -12775,7 +12710,7 @@
                         <a:buNone/>
                       </a:pPr>
                       <a:r>
-                        <a:rPr lang="en-US" sz="1050" dirty="0">
+                        <a:rPr lang="en-US" sz="900" dirty="0">
                           <a:solidFill>
                             <a:srgbClr val="1A1A1A"/>
                           </a:solidFill>
@@ -12783,9 +12718,9 @@
                           <a:ea typeface="Arial" pitchFamily="34" charset="-122"/>
                           <a:cs typeface="Arial" pitchFamily="34" charset="-120"/>
                         </a:rPr>
-                        <a:t>M3: Ø4.0 × 5 gear housing; M2.5: Ø3.45 × 4 encoder</a:t>
+                        <a:t>Ø5.30 bore (10/21), Ø5.45 in v3; 0.5 mm flat</a:t>
                       </a:r>
-                      <a:endParaRPr lang="en-US" sz="1050" dirty="0">
+                      <a:endParaRPr lang="en-US" sz="900" dirty="0">
                         <a:latin typeface="Arial" charset="0"/>
                         <a:ea typeface="Arial" charset="0"/>
                         <a:cs typeface="Arial" charset="0"/>
@@ -12840,7 +12775,7 @@
                         <a:buNone/>
                       </a:pPr>
                       <a:r>
-                        <a:rPr lang="en-US" sz="1050" dirty="0">
+                        <a:rPr lang="en-US" sz="900" dirty="0">
                           <a:solidFill>
                             <a:srgbClr val="1A1A1A"/>
                           </a:solidFill>
@@ -12848,9 +12783,9 @@
                           <a:ea typeface="Arial" pitchFamily="34" charset="-122"/>
                           <a:cs typeface="Arial" pitchFamily="34" charset="-120"/>
                         </a:rPr>
-                        <a:t>Melt-in; hole deeper than the insert</a:t>
+                        <a:t>+0.30 to +0.45: Ø5.2 printed too tight</a:t>
                       </a:r>
-                      <a:endParaRPr lang="en-US" sz="1050" dirty="0">
+                      <a:endParaRPr lang="en-US" sz="900" dirty="0">
                         <a:latin typeface="Arial" charset="0"/>
                         <a:ea typeface="Arial" charset="0"/>
                         <a:cs typeface="Arial" charset="0"/>
@@ -12897,7 +12832,7 @@
                   </a:tcPr>
                 </a:tc>
               </a:tr>
-              <a:tr h="402336">
+              <a:tr h="365760">
                 <a:tc>
                   <a:txBody>
                     <a:bodyPr/>
@@ -12907,7 +12842,7 @@
                         <a:buNone/>
                       </a:pPr>
                       <a:r>
-                        <a:rPr lang="en-US" sz="1050" b="1" dirty="0">
+                        <a:rPr lang="en-US" sz="900" b="1" dirty="0">
                           <a:solidFill>
                             <a:srgbClr val="1A1A1A"/>
                           </a:solidFill>
@@ -12915,9 +12850,9 @@
                           <a:ea typeface="Arial" pitchFamily="34" charset="-122"/>
                           <a:cs typeface="Arial" pitchFamily="34" charset="-120"/>
                         </a:rPr>
-                        <a:t>Screw clearance</a:t>
+                        <a:t>End-stop switch</a:t>
                       </a:r>
-                      <a:endParaRPr lang="en-US" sz="1050" dirty="0">
+                      <a:endParaRPr lang="en-US" sz="900" dirty="0">
                         <a:latin typeface="Arial" charset="0"/>
                         <a:ea typeface="Arial" charset="0"/>
                         <a:cs typeface="Arial" charset="0"/>
@@ -12972,7 +12907,7 @@
                         <a:buNone/>
                       </a:pPr>
                       <a:r>
-                        <a:rPr lang="en-US" sz="1050" dirty="0">
+                        <a:rPr lang="en-US" sz="900" dirty="0">
                           <a:solidFill>
                             <a:srgbClr val="1A1A1A"/>
                           </a:solidFill>
@@ -12980,9 +12915,9 @@
                           <a:ea typeface="Arial" pitchFamily="34" charset="-122"/>
                           <a:cs typeface="Arial" pitchFamily="34" charset="-120"/>
                         </a:rPr>
-                        <a:t>M3 Ø3.5 printed, Ø3.4 drilled; wall Ø3.97 (5/32 in)</a:t>
+                        <a:t>Station slide-in</a:t>
                       </a:r>
-                      <a:endParaRPr lang="en-US" sz="1050" dirty="0">
+                      <a:endParaRPr lang="en-US" sz="900" dirty="0">
                         <a:latin typeface="Arial" charset="0"/>
                         <a:ea typeface="Arial" charset="0"/>
                         <a:cs typeface="Arial" charset="0"/>
@@ -13037,7 +12972,7 @@
                         <a:buNone/>
                       </a:pPr>
                       <a:r>
-                        <a:rPr lang="en-US" sz="1050" dirty="0">
+                        <a:rPr lang="en-US" sz="900" dirty="0">
                           <a:solidFill>
                             <a:srgbClr val="1A1A1A"/>
                           </a:solidFill>
@@ -13045,76 +12980,9 @@
                           <a:ea typeface="Arial" pitchFamily="34" charset="-122"/>
                           <a:cs typeface="Arial" pitchFamily="34" charset="-120"/>
                         </a:rPr>
-                        <a:t>+0.5 printed, +0.4 drilled</a:t>
+                        <a:t>Pocket 6.65 × 20.3 × 9 on a 1 mm ledge, lever window below</a:t>
                       </a:r>
-                      <a:endParaRPr lang="en-US" sz="1050" dirty="0">
-                        <a:latin typeface="Arial" charset="0"/>
-                        <a:ea typeface="Arial" charset="0"/>
-                        <a:cs typeface="Arial" charset="0"/>
-                      </a:endParaRPr>
-                    </a:p>
-                  </a:txBody>
-                  <a:tcPr marL="54864" marR="54864" marT="54864" marB="54864" anchor="ctr">
-                    <a:lnL w="9525" cap="flat" cmpd="sng" algn="ctr">
-                      <a:solidFill>
-                        <a:srgbClr val="BFBFBF"/>
-                      </a:solidFill>
-                      <a:prstDash val="solid"/>
-                      <a:round/>
-                      <a:headEnd type="none" w="med" len="med"/>
-                      <a:tailEnd type="none" w="med" len="med"/>
-                    </a:lnL>
-                    <a:lnR w="9525" cap="flat" cmpd="sng" algn="ctr">
-                      <a:solidFill>
-                        <a:srgbClr val="BFBFBF"/>
-                      </a:solidFill>
-                      <a:prstDash val="solid"/>
-                      <a:round/>
-                      <a:headEnd type="none" w="med" len="med"/>
-                      <a:tailEnd type="none" w="med" len="med"/>
-                    </a:lnR>
-                    <a:lnT w="9525" cap="flat" cmpd="sng" algn="ctr">
-                      <a:solidFill>
-                        <a:srgbClr val="BFBFBF"/>
-                      </a:solidFill>
-                      <a:prstDash val="solid"/>
-                      <a:round/>
-                      <a:headEnd type="none" w="med" len="med"/>
-                      <a:tailEnd type="none" w="med" len="med"/>
-                    </a:lnT>
-                    <a:lnB w="9525" cap="flat" cmpd="sng" algn="ctr">
-                      <a:solidFill>
-                        <a:srgbClr val="BFBFBF"/>
-                      </a:solidFill>
-                      <a:prstDash val="solid"/>
-                      <a:round/>
-                      <a:headEnd type="none" w="med" len="med"/>
-                      <a:tailEnd type="none" w="med" len="med"/>
-                    </a:lnB>
-                  </a:tcPr>
-                </a:tc>
-              </a:tr>
-              <a:tr h="402336">
-                <a:tc>
-                  <a:txBody>
-                    <a:bodyPr/>
-                    <a:lstStyle/>
-                    <a:p>
-                      <a:pPr indent="0" marL="0">
-                        <a:buNone/>
-                      </a:pPr>
-                      <a:r>
-                        <a:rPr lang="en-US" sz="1050" b="1" dirty="0">
-                          <a:solidFill>
-                            <a:srgbClr val="1A1A1A"/>
-                          </a:solidFill>
-                          <a:latin typeface="Arial" pitchFamily="34" charset="0"/>
-                          <a:ea typeface="Arial" pitchFamily="34" charset="-122"/>
-                          <a:cs typeface="Arial" pitchFamily="34" charset="-120"/>
-                        </a:rPr>
-                        <a:t>Motor pilot, Ø22 boss</a:t>
-                      </a:r>
-                      <a:endParaRPr lang="en-US" sz="1050" dirty="0">
+                      <a:endParaRPr lang="en-US" sz="900" dirty="0">
                         <a:latin typeface="Arial" charset="0"/>
                         <a:ea typeface="Arial" charset="0"/>
                         <a:cs typeface="Arial" charset="0"/>
@@ -13169,7 +13037,7 @@
                         <a:buNone/>
                       </a:pPr>
                       <a:r>
-                        <a:rPr lang="en-US" sz="1050" dirty="0">
+                        <a:rPr lang="en-US" sz="900" dirty="0">
                           <a:solidFill>
                             <a:srgbClr val="1A1A1A"/>
                           </a:solidFill>
@@ -13177,9 +13045,76 @@
                           <a:ea typeface="Arial" pitchFamily="34" charset="-122"/>
                           <a:cs typeface="Arial" pitchFamily="34" charset="-120"/>
                         </a:rPr>
-                        <a:t>Ø22.4 printed tab, Ø22.5 drilled fin</a:t>
+                        <a:t>Press fit, no screws</a:t>
                       </a:r>
-                      <a:endParaRPr lang="en-US" sz="1050" dirty="0">
+                      <a:endParaRPr lang="en-US" sz="900" dirty="0">
+                        <a:latin typeface="Arial" charset="0"/>
+                        <a:ea typeface="Arial" charset="0"/>
+                        <a:cs typeface="Arial" charset="0"/>
+                      </a:endParaRPr>
+                    </a:p>
+                  </a:txBody>
+                  <a:tcPr marL="54864" marR="54864" marT="54864" marB="54864" anchor="ctr">
+                    <a:lnL w="9525" cap="flat" cmpd="sng" algn="ctr">
+                      <a:solidFill>
+                        <a:srgbClr val="BFBFBF"/>
+                      </a:solidFill>
+                      <a:prstDash val="solid"/>
+                      <a:round/>
+                      <a:headEnd type="none" w="med" len="med"/>
+                      <a:tailEnd type="none" w="med" len="med"/>
+                    </a:lnL>
+                    <a:lnR w="9525" cap="flat" cmpd="sng" algn="ctr">
+                      <a:solidFill>
+                        <a:srgbClr val="BFBFBF"/>
+                      </a:solidFill>
+                      <a:prstDash val="solid"/>
+                      <a:round/>
+                      <a:headEnd type="none" w="med" len="med"/>
+                      <a:tailEnd type="none" w="med" len="med"/>
+                    </a:lnR>
+                    <a:lnT w="9525" cap="flat" cmpd="sng" algn="ctr">
+                      <a:solidFill>
+                        <a:srgbClr val="BFBFBF"/>
+                      </a:solidFill>
+                      <a:prstDash val="solid"/>
+                      <a:round/>
+                      <a:headEnd type="none" w="med" len="med"/>
+                      <a:tailEnd type="none" w="med" len="med"/>
+                    </a:lnT>
+                    <a:lnB w="9525" cap="flat" cmpd="sng" algn="ctr">
+                      <a:solidFill>
+                        <a:srgbClr val="BFBFBF"/>
+                      </a:solidFill>
+                      <a:prstDash val="solid"/>
+                      <a:round/>
+                      <a:headEnd type="none" w="med" len="med"/>
+                      <a:tailEnd type="none" w="med" len="med"/>
+                    </a:lnB>
+                  </a:tcPr>
+                </a:tc>
+              </a:tr>
+              <a:tr h="365760">
+                <a:tc>
+                  <a:txBody>
+                    <a:bodyPr/>
+                    <a:lstStyle/>
+                    <a:p>
+                      <a:pPr indent="0" marL="0">
+                        <a:buNone/>
+                      </a:pPr>
+                      <a:r>
+                        <a:rPr lang="en-US" sz="900" b="1" dirty="0">
+                          <a:solidFill>
+                            <a:srgbClr val="1A1A1A"/>
+                          </a:solidFill>
+                          <a:latin typeface="Arial" pitchFamily="34" charset="0"/>
+                          <a:ea typeface="Arial" pitchFamily="34" charset="-122"/>
+                          <a:cs typeface="Arial" pitchFamily="34" charset="-120"/>
+                        </a:rPr>
+                        <a:t>Heat-set inserts</a:t>
+                      </a:r>
+                      <a:endParaRPr lang="en-US" sz="900" dirty="0">
                         <a:latin typeface="Arial" charset="0"/>
                         <a:ea typeface="Arial" charset="0"/>
                         <a:cs typeface="Arial" charset="0"/>
@@ -13234,7 +13169,7 @@
                         <a:buNone/>
                       </a:pPr>
                       <a:r>
-                        <a:rPr lang="en-US" sz="1050" dirty="0">
+                        <a:rPr lang="en-US" sz="900" dirty="0">
                           <a:solidFill>
                             <a:srgbClr val="1A1A1A"/>
                           </a:solidFill>
@@ -13242,76 +13177,9 @@
                           <a:ea typeface="Arial" pitchFamily="34" charset="-122"/>
                           <a:cs typeface="Arial" pitchFamily="34" charset="-120"/>
                         </a:rPr>
-                        <a:t>+0.4 / +0.5</a:t>
+                        <a:t>Claw gear housing (M3); encoder board (M2.5)</a:t>
                       </a:r>
-                      <a:endParaRPr lang="en-US" sz="1050" dirty="0">
-                        <a:latin typeface="Arial" charset="0"/>
-                        <a:ea typeface="Arial" charset="0"/>
-                        <a:cs typeface="Arial" charset="0"/>
-                      </a:endParaRPr>
-                    </a:p>
-                  </a:txBody>
-                  <a:tcPr marL="54864" marR="54864" marT="54864" marB="54864" anchor="ctr">
-                    <a:lnL w="9525" cap="flat" cmpd="sng" algn="ctr">
-                      <a:solidFill>
-                        <a:srgbClr val="BFBFBF"/>
-                      </a:solidFill>
-                      <a:prstDash val="solid"/>
-                      <a:round/>
-                      <a:headEnd type="none" w="med" len="med"/>
-                      <a:tailEnd type="none" w="med" len="med"/>
-                    </a:lnL>
-                    <a:lnR w="9525" cap="flat" cmpd="sng" algn="ctr">
-                      <a:solidFill>
-                        <a:srgbClr val="BFBFBF"/>
-                      </a:solidFill>
-                      <a:prstDash val="solid"/>
-                      <a:round/>
-                      <a:headEnd type="none" w="med" len="med"/>
-                      <a:tailEnd type="none" w="med" len="med"/>
-                    </a:lnR>
-                    <a:lnT w="9525" cap="flat" cmpd="sng" algn="ctr">
-                      <a:solidFill>
-                        <a:srgbClr val="BFBFBF"/>
-                      </a:solidFill>
-                      <a:prstDash val="solid"/>
-                      <a:round/>
-                      <a:headEnd type="none" w="med" len="med"/>
-                      <a:tailEnd type="none" w="med" len="med"/>
-                    </a:lnT>
-                    <a:lnB w="9525" cap="flat" cmpd="sng" algn="ctr">
-                      <a:solidFill>
-                        <a:srgbClr val="BFBFBF"/>
-                      </a:solidFill>
-                      <a:prstDash val="solid"/>
-                      <a:round/>
-                      <a:headEnd type="none" w="med" len="med"/>
-                      <a:tailEnd type="none" w="med" len="med"/>
-                    </a:lnB>
-                  </a:tcPr>
-                </a:tc>
-              </a:tr>
-              <a:tr h="402336">
-                <a:tc>
-                  <a:txBody>
-                    <a:bodyPr/>
-                    <a:lstStyle/>
-                    <a:p>
-                      <a:pPr indent="0" marL="0">
-                        <a:buNone/>
-                      </a:pPr>
-                      <a:r>
-                        <a:rPr lang="en-US" sz="1050" b="1" dirty="0">
-                          <a:solidFill>
-                            <a:srgbClr val="1A1A1A"/>
-                          </a:solidFill>
-                          <a:latin typeface="Arial" pitchFamily="34" charset="0"/>
-                          <a:ea typeface="Arial" pitchFamily="34" charset="-122"/>
-                          <a:cs typeface="Arial" pitchFamily="34" charset="-120"/>
-                        </a:rPr>
-                        <a:t>Fin hole zero</a:t>
-                      </a:r>
-                      <a:endParaRPr lang="en-US" sz="1050" dirty="0">
+                      <a:endParaRPr lang="en-US" sz="900" dirty="0">
                         <a:latin typeface="Arial" charset="0"/>
                         <a:ea typeface="Arial" charset="0"/>
                         <a:cs typeface="Arial" charset="0"/>
@@ -13366,7 +13234,7 @@
                         <a:buNone/>
                       </a:pPr>
                       <a:r>
-                        <a:rPr lang="en-US" sz="1050" dirty="0">
+                        <a:rPr lang="en-US" sz="900" dirty="0">
                           <a:solidFill>
                             <a:srgbClr val="1A1A1A"/>
                           </a:solidFill>
@@ -13374,9 +13242,9 @@
                           <a:ea typeface="Arial" pitchFamily="34" charset="-122"/>
                           <a:cs typeface="Arial" pitchFamily="34" charset="-120"/>
                         </a:rPr>
-                        <a:t>Edges locate the bottom-left hole; drilled, it is the zero for the other 4</a:t>
+                        <a:t>M3: Ø4.0 × 5; M2.5: Ø3.45 × 4</a:t>
                       </a:r>
-                      <a:endParaRPr lang="en-US" sz="1050" dirty="0">
+                      <a:endParaRPr lang="en-US" sz="900" dirty="0">
                         <a:latin typeface="Arial" charset="0"/>
                         <a:ea typeface="Arial" charset="0"/>
                         <a:cs typeface="Arial" charset="0"/>
@@ -13431,7 +13299,793 @@
                         <a:buNone/>
                       </a:pPr>
                       <a:r>
-                        <a:rPr lang="en-US" sz="1050" dirty="0">
+                        <a:rPr lang="en-US" sz="900" dirty="0">
+                          <a:solidFill>
+                            <a:srgbClr val="1A1A1A"/>
+                          </a:solidFill>
+                          <a:latin typeface="Arial" pitchFamily="34" charset="0"/>
+                          <a:ea typeface="Arial" pitchFamily="34" charset="-122"/>
+                          <a:cs typeface="Arial" pitchFamily="34" charset="-120"/>
+                        </a:rPr>
+                        <a:t>Melt-in; hole deeper than the insert</a:t>
+                      </a:r>
+                      <a:endParaRPr lang="en-US" sz="900" dirty="0">
+                        <a:latin typeface="Arial" charset="0"/>
+                        <a:ea typeface="Arial" charset="0"/>
+                        <a:cs typeface="Arial" charset="0"/>
+                      </a:endParaRPr>
+                    </a:p>
+                  </a:txBody>
+                  <a:tcPr marL="54864" marR="54864" marT="54864" marB="54864" anchor="ctr">
+                    <a:lnL w="9525" cap="flat" cmpd="sng" algn="ctr">
+                      <a:solidFill>
+                        <a:srgbClr val="BFBFBF"/>
+                      </a:solidFill>
+                      <a:prstDash val="solid"/>
+                      <a:round/>
+                      <a:headEnd type="none" w="med" len="med"/>
+                      <a:tailEnd type="none" w="med" len="med"/>
+                    </a:lnL>
+                    <a:lnR w="9525" cap="flat" cmpd="sng" algn="ctr">
+                      <a:solidFill>
+                        <a:srgbClr val="BFBFBF"/>
+                      </a:solidFill>
+                      <a:prstDash val="solid"/>
+                      <a:round/>
+                      <a:headEnd type="none" w="med" len="med"/>
+                      <a:tailEnd type="none" w="med" len="med"/>
+                    </a:lnR>
+                    <a:lnT w="9525" cap="flat" cmpd="sng" algn="ctr">
+                      <a:solidFill>
+                        <a:srgbClr val="BFBFBF"/>
+                      </a:solidFill>
+                      <a:prstDash val="solid"/>
+                      <a:round/>
+                      <a:headEnd type="none" w="med" len="med"/>
+                      <a:tailEnd type="none" w="med" len="med"/>
+                    </a:lnT>
+                    <a:lnB w="9525" cap="flat" cmpd="sng" algn="ctr">
+                      <a:solidFill>
+                        <a:srgbClr val="BFBFBF"/>
+                      </a:solidFill>
+                      <a:prstDash val="solid"/>
+                      <a:round/>
+                      <a:headEnd type="none" w="med" len="med"/>
+                      <a:tailEnd type="none" w="med" len="med"/>
+                    </a:lnB>
+                  </a:tcPr>
+                </a:tc>
+              </a:tr>
+              <a:tr h="365760">
+                <a:tc>
+                  <a:txBody>
+                    <a:bodyPr/>
+                    <a:lstStyle/>
+                    <a:p>
+                      <a:pPr indent="0" marL="0">
+                        <a:buNone/>
+                      </a:pPr>
+                      <a:r>
+                        <a:rPr lang="en-US" sz="900" b="1" dirty="0">
+                          <a:solidFill>
+                            <a:srgbClr val="1A1A1A"/>
+                          </a:solidFill>
+                          <a:latin typeface="Arial" pitchFamily="34" charset="0"/>
+                          <a:ea typeface="Arial" pitchFamily="34" charset="-122"/>
+                          <a:cs typeface="Arial" pitchFamily="34" charset="-120"/>
+                        </a:rPr>
+                        <a:t>Screw clearance</a:t>
+                      </a:r>
+                      <a:endParaRPr lang="en-US" sz="900" dirty="0">
+                        <a:latin typeface="Arial" charset="0"/>
+                        <a:ea typeface="Arial" charset="0"/>
+                        <a:cs typeface="Arial" charset="0"/>
+                      </a:endParaRPr>
+                    </a:p>
+                  </a:txBody>
+                  <a:tcPr marL="54864" marR="54864" marT="54864" marB="54864" anchor="ctr">
+                    <a:lnL w="9525" cap="flat" cmpd="sng" algn="ctr">
+                      <a:solidFill>
+                        <a:srgbClr val="BFBFBF"/>
+                      </a:solidFill>
+                      <a:prstDash val="solid"/>
+                      <a:round/>
+                      <a:headEnd type="none" w="med" len="med"/>
+                      <a:tailEnd type="none" w="med" len="med"/>
+                    </a:lnL>
+                    <a:lnR w="9525" cap="flat" cmpd="sng" algn="ctr">
+                      <a:solidFill>
+                        <a:srgbClr val="BFBFBF"/>
+                      </a:solidFill>
+                      <a:prstDash val="solid"/>
+                      <a:round/>
+                      <a:headEnd type="none" w="med" len="med"/>
+                      <a:tailEnd type="none" w="med" len="med"/>
+                    </a:lnR>
+                    <a:lnT w="9525" cap="flat" cmpd="sng" algn="ctr">
+                      <a:solidFill>
+                        <a:srgbClr val="BFBFBF"/>
+                      </a:solidFill>
+                      <a:prstDash val="solid"/>
+                      <a:round/>
+                      <a:headEnd type="none" w="med" len="med"/>
+                      <a:tailEnd type="none" w="med" len="med"/>
+                    </a:lnT>
+                    <a:lnB w="9525" cap="flat" cmpd="sng" algn="ctr">
+                      <a:solidFill>
+                        <a:srgbClr val="BFBFBF"/>
+                      </a:solidFill>
+                      <a:prstDash val="solid"/>
+                      <a:round/>
+                      <a:headEnd type="none" w="med" len="med"/>
+                      <a:tailEnd type="none" w="med" len="med"/>
+                    </a:lnB>
+                  </a:tcPr>
+                </a:tc>
+                <a:tc>
+                  <a:txBody>
+                    <a:bodyPr/>
+                    <a:lstStyle/>
+                    <a:p>
+                      <a:pPr indent="0" marL="0">
+                        <a:buNone/>
+                      </a:pPr>
+                      <a:r>
+                        <a:rPr lang="en-US" sz="900" dirty="0">
+                          <a:solidFill>
+                            <a:srgbClr val="1A1A1A"/>
+                          </a:solidFill>
+                          <a:latin typeface="Arial" pitchFamily="34" charset="0"/>
+                          <a:ea typeface="Arial" pitchFamily="34" charset="-122"/>
+                          <a:cs typeface="Arial" pitchFamily="34" charset="-120"/>
+                        </a:rPr>
+                        <a:t>Printed parts, fin, wall mount</a:t>
+                      </a:r>
+                      <a:endParaRPr lang="en-US" sz="900" dirty="0">
+                        <a:latin typeface="Arial" charset="0"/>
+                        <a:ea typeface="Arial" charset="0"/>
+                        <a:cs typeface="Arial" charset="0"/>
+                      </a:endParaRPr>
+                    </a:p>
+                  </a:txBody>
+                  <a:tcPr marL="54864" marR="54864" marT="54864" marB="54864" anchor="ctr">
+                    <a:lnL w="9525" cap="flat" cmpd="sng" algn="ctr">
+                      <a:solidFill>
+                        <a:srgbClr val="BFBFBF"/>
+                      </a:solidFill>
+                      <a:prstDash val="solid"/>
+                      <a:round/>
+                      <a:headEnd type="none" w="med" len="med"/>
+                      <a:tailEnd type="none" w="med" len="med"/>
+                    </a:lnL>
+                    <a:lnR w="9525" cap="flat" cmpd="sng" algn="ctr">
+                      <a:solidFill>
+                        <a:srgbClr val="BFBFBF"/>
+                      </a:solidFill>
+                      <a:prstDash val="solid"/>
+                      <a:round/>
+                      <a:headEnd type="none" w="med" len="med"/>
+                      <a:tailEnd type="none" w="med" len="med"/>
+                    </a:lnR>
+                    <a:lnT w="9525" cap="flat" cmpd="sng" algn="ctr">
+                      <a:solidFill>
+                        <a:srgbClr val="BFBFBF"/>
+                      </a:solidFill>
+                      <a:prstDash val="solid"/>
+                      <a:round/>
+                      <a:headEnd type="none" w="med" len="med"/>
+                      <a:tailEnd type="none" w="med" len="med"/>
+                    </a:lnT>
+                    <a:lnB w="9525" cap="flat" cmpd="sng" algn="ctr">
+                      <a:solidFill>
+                        <a:srgbClr val="BFBFBF"/>
+                      </a:solidFill>
+                      <a:prstDash val="solid"/>
+                      <a:round/>
+                      <a:headEnd type="none" w="med" len="med"/>
+                      <a:tailEnd type="none" w="med" len="med"/>
+                    </a:lnB>
+                  </a:tcPr>
+                </a:tc>
+                <a:tc>
+                  <a:txBody>
+                    <a:bodyPr/>
+                    <a:lstStyle/>
+                    <a:p>
+                      <a:pPr indent="0" marL="0">
+                        <a:buNone/>
+                      </a:pPr>
+                      <a:r>
+                        <a:rPr lang="en-US" sz="900" dirty="0">
+                          <a:solidFill>
+                            <a:srgbClr val="1A1A1A"/>
+                          </a:solidFill>
+                          <a:latin typeface="Arial" pitchFamily="34" charset="0"/>
+                          <a:ea typeface="Arial" pitchFamily="34" charset="-122"/>
+                          <a:cs typeface="Arial" pitchFamily="34" charset="-120"/>
+                        </a:rPr>
+                        <a:t>M3 Ø3.5 printed, Ø3.4 drilled; wall Ø3.97 (5/32 in)</a:t>
+                      </a:r>
+                      <a:endParaRPr lang="en-US" sz="900" dirty="0">
+                        <a:latin typeface="Arial" charset="0"/>
+                        <a:ea typeface="Arial" charset="0"/>
+                        <a:cs typeface="Arial" charset="0"/>
+                      </a:endParaRPr>
+                    </a:p>
+                  </a:txBody>
+                  <a:tcPr marL="54864" marR="54864" marT="54864" marB="54864" anchor="ctr">
+                    <a:lnL w="9525" cap="flat" cmpd="sng" algn="ctr">
+                      <a:solidFill>
+                        <a:srgbClr val="BFBFBF"/>
+                      </a:solidFill>
+                      <a:prstDash val="solid"/>
+                      <a:round/>
+                      <a:headEnd type="none" w="med" len="med"/>
+                      <a:tailEnd type="none" w="med" len="med"/>
+                    </a:lnL>
+                    <a:lnR w="9525" cap="flat" cmpd="sng" algn="ctr">
+                      <a:solidFill>
+                        <a:srgbClr val="BFBFBF"/>
+                      </a:solidFill>
+                      <a:prstDash val="solid"/>
+                      <a:round/>
+                      <a:headEnd type="none" w="med" len="med"/>
+                      <a:tailEnd type="none" w="med" len="med"/>
+                    </a:lnR>
+                    <a:lnT w="9525" cap="flat" cmpd="sng" algn="ctr">
+                      <a:solidFill>
+                        <a:srgbClr val="BFBFBF"/>
+                      </a:solidFill>
+                      <a:prstDash val="solid"/>
+                      <a:round/>
+                      <a:headEnd type="none" w="med" len="med"/>
+                      <a:tailEnd type="none" w="med" len="med"/>
+                    </a:lnT>
+                    <a:lnB w="9525" cap="flat" cmpd="sng" algn="ctr">
+                      <a:solidFill>
+                        <a:srgbClr val="BFBFBF"/>
+                      </a:solidFill>
+                      <a:prstDash val="solid"/>
+                      <a:round/>
+                      <a:headEnd type="none" w="med" len="med"/>
+                      <a:tailEnd type="none" w="med" len="med"/>
+                    </a:lnB>
+                  </a:tcPr>
+                </a:tc>
+                <a:tc>
+                  <a:txBody>
+                    <a:bodyPr/>
+                    <a:lstStyle/>
+                    <a:p>
+                      <a:pPr indent="0" marL="0">
+                        <a:buNone/>
+                      </a:pPr>
+                      <a:r>
+                        <a:rPr lang="en-US" sz="900" dirty="0">
+                          <a:solidFill>
+                            <a:srgbClr val="1A1A1A"/>
+                          </a:solidFill>
+                          <a:latin typeface="Arial" pitchFamily="34" charset="0"/>
+                          <a:ea typeface="Arial" pitchFamily="34" charset="-122"/>
+                          <a:cs typeface="Arial" pitchFamily="34" charset="-120"/>
+                        </a:rPr>
+                        <a:t>+0.5 printed, +0.4 drilled</a:t>
+                      </a:r>
+                      <a:endParaRPr lang="en-US" sz="900" dirty="0">
+                        <a:latin typeface="Arial" charset="0"/>
+                        <a:ea typeface="Arial" charset="0"/>
+                        <a:cs typeface="Arial" charset="0"/>
+                      </a:endParaRPr>
+                    </a:p>
+                  </a:txBody>
+                  <a:tcPr marL="54864" marR="54864" marT="54864" marB="54864" anchor="ctr">
+                    <a:lnL w="9525" cap="flat" cmpd="sng" algn="ctr">
+                      <a:solidFill>
+                        <a:srgbClr val="BFBFBF"/>
+                      </a:solidFill>
+                      <a:prstDash val="solid"/>
+                      <a:round/>
+                      <a:headEnd type="none" w="med" len="med"/>
+                      <a:tailEnd type="none" w="med" len="med"/>
+                    </a:lnL>
+                    <a:lnR w="9525" cap="flat" cmpd="sng" algn="ctr">
+                      <a:solidFill>
+                        <a:srgbClr val="BFBFBF"/>
+                      </a:solidFill>
+                      <a:prstDash val="solid"/>
+                      <a:round/>
+                      <a:headEnd type="none" w="med" len="med"/>
+                      <a:tailEnd type="none" w="med" len="med"/>
+                    </a:lnR>
+                    <a:lnT w="9525" cap="flat" cmpd="sng" algn="ctr">
+                      <a:solidFill>
+                        <a:srgbClr val="BFBFBF"/>
+                      </a:solidFill>
+                      <a:prstDash val="solid"/>
+                      <a:round/>
+                      <a:headEnd type="none" w="med" len="med"/>
+                      <a:tailEnd type="none" w="med" len="med"/>
+                    </a:lnT>
+                    <a:lnB w="9525" cap="flat" cmpd="sng" algn="ctr">
+                      <a:solidFill>
+                        <a:srgbClr val="BFBFBF"/>
+                      </a:solidFill>
+                      <a:prstDash val="solid"/>
+                      <a:round/>
+                      <a:headEnd type="none" w="med" len="med"/>
+                      <a:tailEnd type="none" w="med" len="med"/>
+                    </a:lnB>
+                  </a:tcPr>
+                </a:tc>
+              </a:tr>
+              <a:tr h="365760">
+                <a:tc>
+                  <a:txBody>
+                    <a:bodyPr/>
+                    <a:lstStyle/>
+                    <a:p>
+                      <a:pPr indent="0" marL="0">
+                        <a:buNone/>
+                      </a:pPr>
+                      <a:r>
+                        <a:rPr lang="en-US" sz="900" b="1" dirty="0">
+                          <a:solidFill>
+                            <a:srgbClr val="1A1A1A"/>
+                          </a:solidFill>
+                          <a:latin typeface="Arial" pitchFamily="34" charset="0"/>
+                          <a:ea typeface="Arial" pitchFamily="34" charset="-122"/>
+                          <a:cs typeface="Arial" pitchFamily="34" charset="-120"/>
+                        </a:rPr>
+                        <a:t>Motor pilot, Ø22 boss</a:t>
+                      </a:r>
+                      <a:endParaRPr lang="en-US" sz="900" dirty="0">
+                        <a:latin typeface="Arial" charset="0"/>
+                        <a:ea typeface="Arial" charset="0"/>
+                        <a:cs typeface="Arial" charset="0"/>
+                      </a:endParaRPr>
+                    </a:p>
+                  </a:txBody>
+                  <a:tcPr marL="54864" marR="54864" marT="54864" marB="54864" anchor="ctr">
+                    <a:lnL w="9525" cap="flat" cmpd="sng" algn="ctr">
+                      <a:solidFill>
+                        <a:srgbClr val="BFBFBF"/>
+                      </a:solidFill>
+                      <a:prstDash val="solid"/>
+                      <a:round/>
+                      <a:headEnd type="none" w="med" len="med"/>
+                      <a:tailEnd type="none" w="med" len="med"/>
+                    </a:lnL>
+                    <a:lnR w="9525" cap="flat" cmpd="sng" algn="ctr">
+                      <a:solidFill>
+                        <a:srgbClr val="BFBFBF"/>
+                      </a:solidFill>
+                      <a:prstDash val="solid"/>
+                      <a:round/>
+                      <a:headEnd type="none" w="med" len="med"/>
+                      <a:tailEnd type="none" w="med" len="med"/>
+                    </a:lnR>
+                    <a:lnT w="9525" cap="flat" cmpd="sng" algn="ctr">
+                      <a:solidFill>
+                        <a:srgbClr val="BFBFBF"/>
+                      </a:solidFill>
+                      <a:prstDash val="solid"/>
+                      <a:round/>
+                      <a:headEnd type="none" w="med" len="med"/>
+                      <a:tailEnd type="none" w="med" len="med"/>
+                    </a:lnT>
+                    <a:lnB w="9525" cap="flat" cmpd="sng" algn="ctr">
+                      <a:solidFill>
+                        <a:srgbClr val="BFBFBF"/>
+                      </a:solidFill>
+                      <a:prstDash val="solid"/>
+                      <a:round/>
+                      <a:headEnd type="none" w="med" len="med"/>
+                      <a:tailEnd type="none" w="med" len="med"/>
+                    </a:lnB>
+                  </a:tcPr>
+                </a:tc>
+                <a:tc>
+                  <a:txBody>
+                    <a:bodyPr/>
+                    <a:lstStyle/>
+                    <a:p>
+                      <a:pPr indent="0" marL="0">
+                        <a:buNone/>
+                      </a:pPr>
+                      <a:r>
+                        <a:rPr lang="en-US" sz="900" dirty="0">
+                          <a:solidFill>
+                            <a:srgbClr val="1A1A1A"/>
+                          </a:solidFill>
+                          <a:latin typeface="Arial" pitchFamily="34" charset="0"/>
+                          <a:ea typeface="Arial" pitchFamily="34" charset="-122"/>
+                          <a:cs typeface="Arial" pitchFamily="34" charset="-120"/>
+                        </a:rPr>
+                        <a:t>Motor tab and fin</a:t>
+                      </a:r>
+                      <a:endParaRPr lang="en-US" sz="900" dirty="0">
+                        <a:latin typeface="Arial" charset="0"/>
+                        <a:ea typeface="Arial" charset="0"/>
+                        <a:cs typeface="Arial" charset="0"/>
+                      </a:endParaRPr>
+                    </a:p>
+                  </a:txBody>
+                  <a:tcPr marL="54864" marR="54864" marT="54864" marB="54864" anchor="ctr">
+                    <a:lnL w="9525" cap="flat" cmpd="sng" algn="ctr">
+                      <a:solidFill>
+                        <a:srgbClr val="BFBFBF"/>
+                      </a:solidFill>
+                      <a:prstDash val="solid"/>
+                      <a:round/>
+                      <a:headEnd type="none" w="med" len="med"/>
+                      <a:tailEnd type="none" w="med" len="med"/>
+                    </a:lnL>
+                    <a:lnR w="9525" cap="flat" cmpd="sng" algn="ctr">
+                      <a:solidFill>
+                        <a:srgbClr val="BFBFBF"/>
+                      </a:solidFill>
+                      <a:prstDash val="solid"/>
+                      <a:round/>
+                      <a:headEnd type="none" w="med" len="med"/>
+                      <a:tailEnd type="none" w="med" len="med"/>
+                    </a:lnR>
+                    <a:lnT w="9525" cap="flat" cmpd="sng" algn="ctr">
+                      <a:solidFill>
+                        <a:srgbClr val="BFBFBF"/>
+                      </a:solidFill>
+                      <a:prstDash val="solid"/>
+                      <a:round/>
+                      <a:headEnd type="none" w="med" len="med"/>
+                      <a:tailEnd type="none" w="med" len="med"/>
+                    </a:lnT>
+                    <a:lnB w="9525" cap="flat" cmpd="sng" algn="ctr">
+                      <a:solidFill>
+                        <a:srgbClr val="BFBFBF"/>
+                      </a:solidFill>
+                      <a:prstDash val="solid"/>
+                      <a:round/>
+                      <a:headEnd type="none" w="med" len="med"/>
+                      <a:tailEnd type="none" w="med" len="med"/>
+                    </a:lnB>
+                  </a:tcPr>
+                </a:tc>
+                <a:tc>
+                  <a:txBody>
+                    <a:bodyPr/>
+                    <a:lstStyle/>
+                    <a:p>
+                      <a:pPr indent="0" marL="0">
+                        <a:buNone/>
+                      </a:pPr>
+                      <a:r>
+                        <a:rPr lang="en-US" sz="900" dirty="0">
+                          <a:solidFill>
+                            <a:srgbClr val="1A1A1A"/>
+                          </a:solidFill>
+                          <a:latin typeface="Arial" pitchFamily="34" charset="0"/>
+                          <a:ea typeface="Arial" pitchFamily="34" charset="-122"/>
+                          <a:cs typeface="Arial" pitchFamily="34" charset="-120"/>
+                        </a:rPr>
+                        <a:t>Ø22.4 printed tab, Ø22.5 drilled fin</a:t>
+                      </a:r>
+                      <a:endParaRPr lang="en-US" sz="900" dirty="0">
+                        <a:latin typeface="Arial" charset="0"/>
+                        <a:ea typeface="Arial" charset="0"/>
+                        <a:cs typeface="Arial" charset="0"/>
+                      </a:endParaRPr>
+                    </a:p>
+                  </a:txBody>
+                  <a:tcPr marL="54864" marR="54864" marT="54864" marB="54864" anchor="ctr">
+                    <a:lnL w="9525" cap="flat" cmpd="sng" algn="ctr">
+                      <a:solidFill>
+                        <a:srgbClr val="BFBFBF"/>
+                      </a:solidFill>
+                      <a:prstDash val="solid"/>
+                      <a:round/>
+                      <a:headEnd type="none" w="med" len="med"/>
+                      <a:tailEnd type="none" w="med" len="med"/>
+                    </a:lnL>
+                    <a:lnR w="9525" cap="flat" cmpd="sng" algn="ctr">
+                      <a:solidFill>
+                        <a:srgbClr val="BFBFBF"/>
+                      </a:solidFill>
+                      <a:prstDash val="solid"/>
+                      <a:round/>
+                      <a:headEnd type="none" w="med" len="med"/>
+                      <a:tailEnd type="none" w="med" len="med"/>
+                    </a:lnR>
+                    <a:lnT w="9525" cap="flat" cmpd="sng" algn="ctr">
+                      <a:solidFill>
+                        <a:srgbClr val="BFBFBF"/>
+                      </a:solidFill>
+                      <a:prstDash val="solid"/>
+                      <a:round/>
+                      <a:headEnd type="none" w="med" len="med"/>
+                      <a:tailEnd type="none" w="med" len="med"/>
+                    </a:lnT>
+                    <a:lnB w="9525" cap="flat" cmpd="sng" algn="ctr">
+                      <a:solidFill>
+                        <a:srgbClr val="BFBFBF"/>
+                      </a:solidFill>
+                      <a:prstDash val="solid"/>
+                      <a:round/>
+                      <a:headEnd type="none" w="med" len="med"/>
+                      <a:tailEnd type="none" w="med" len="med"/>
+                    </a:lnB>
+                  </a:tcPr>
+                </a:tc>
+                <a:tc>
+                  <a:txBody>
+                    <a:bodyPr/>
+                    <a:lstStyle/>
+                    <a:p>
+                      <a:pPr indent="0" marL="0">
+                        <a:buNone/>
+                      </a:pPr>
+                      <a:r>
+                        <a:rPr lang="en-US" sz="900" dirty="0">
+                          <a:solidFill>
+                            <a:srgbClr val="1A1A1A"/>
+                          </a:solidFill>
+                          <a:latin typeface="Arial" pitchFamily="34" charset="0"/>
+                          <a:ea typeface="Arial" pitchFamily="34" charset="-122"/>
+                          <a:cs typeface="Arial" pitchFamily="34" charset="-120"/>
+                        </a:rPr>
+                        <a:t>+0.4 / +0.5</a:t>
+                      </a:r>
+                      <a:endParaRPr lang="en-US" sz="900" dirty="0">
+                        <a:latin typeface="Arial" charset="0"/>
+                        <a:ea typeface="Arial" charset="0"/>
+                        <a:cs typeface="Arial" charset="0"/>
+                      </a:endParaRPr>
+                    </a:p>
+                  </a:txBody>
+                  <a:tcPr marL="54864" marR="54864" marT="54864" marB="54864" anchor="ctr">
+                    <a:lnL w="9525" cap="flat" cmpd="sng" algn="ctr">
+                      <a:solidFill>
+                        <a:srgbClr val="BFBFBF"/>
+                      </a:solidFill>
+                      <a:prstDash val="solid"/>
+                      <a:round/>
+                      <a:headEnd type="none" w="med" len="med"/>
+                      <a:tailEnd type="none" w="med" len="med"/>
+                    </a:lnL>
+                    <a:lnR w="9525" cap="flat" cmpd="sng" algn="ctr">
+                      <a:solidFill>
+                        <a:srgbClr val="BFBFBF"/>
+                      </a:solidFill>
+                      <a:prstDash val="solid"/>
+                      <a:round/>
+                      <a:headEnd type="none" w="med" len="med"/>
+                      <a:tailEnd type="none" w="med" len="med"/>
+                    </a:lnR>
+                    <a:lnT w="9525" cap="flat" cmpd="sng" algn="ctr">
+                      <a:solidFill>
+                        <a:srgbClr val="BFBFBF"/>
+                      </a:solidFill>
+                      <a:prstDash val="solid"/>
+                      <a:round/>
+                      <a:headEnd type="none" w="med" len="med"/>
+                      <a:tailEnd type="none" w="med" len="med"/>
+                    </a:lnT>
+                    <a:lnB w="9525" cap="flat" cmpd="sng" algn="ctr">
+                      <a:solidFill>
+                        <a:srgbClr val="BFBFBF"/>
+                      </a:solidFill>
+                      <a:prstDash val="solid"/>
+                      <a:round/>
+                      <a:headEnd type="none" w="med" len="med"/>
+                      <a:tailEnd type="none" w="med" len="med"/>
+                    </a:lnB>
+                  </a:tcPr>
+                </a:tc>
+              </a:tr>
+              <a:tr h="365760">
+                <a:tc>
+                  <a:txBody>
+                    <a:bodyPr/>
+                    <a:lstStyle/>
+                    <a:p>
+                      <a:pPr indent="0" marL="0">
+                        <a:buNone/>
+                      </a:pPr>
+                      <a:r>
+                        <a:rPr lang="en-US" sz="900" b="1" dirty="0">
+                          <a:solidFill>
+                            <a:srgbClr val="1A1A1A"/>
+                          </a:solidFill>
+                          <a:latin typeface="Arial" pitchFamily="34" charset="0"/>
+                          <a:ea typeface="Arial" pitchFamily="34" charset="-122"/>
+                          <a:cs typeface="Arial" pitchFamily="34" charset="-120"/>
+                        </a:rPr>
+                        <a:t>Fin hole zero</a:t>
+                      </a:r>
+                      <a:endParaRPr lang="en-US" sz="900" dirty="0">
+                        <a:latin typeface="Arial" charset="0"/>
+                        <a:ea typeface="Arial" charset="0"/>
+                        <a:cs typeface="Arial" charset="0"/>
+                      </a:endParaRPr>
+                    </a:p>
+                  </a:txBody>
+                  <a:tcPr marL="54864" marR="54864" marT="54864" marB="54864" anchor="ctr">
+                    <a:lnL w="9525" cap="flat" cmpd="sng" algn="ctr">
+                      <a:solidFill>
+                        <a:srgbClr val="BFBFBF"/>
+                      </a:solidFill>
+                      <a:prstDash val="solid"/>
+                      <a:round/>
+                      <a:headEnd type="none" w="med" len="med"/>
+                      <a:tailEnd type="none" w="med" len="med"/>
+                    </a:lnL>
+                    <a:lnR w="9525" cap="flat" cmpd="sng" algn="ctr">
+                      <a:solidFill>
+                        <a:srgbClr val="BFBFBF"/>
+                      </a:solidFill>
+                      <a:prstDash val="solid"/>
+                      <a:round/>
+                      <a:headEnd type="none" w="med" len="med"/>
+                      <a:tailEnd type="none" w="med" len="med"/>
+                    </a:lnR>
+                    <a:lnT w="9525" cap="flat" cmpd="sng" algn="ctr">
+                      <a:solidFill>
+                        <a:srgbClr val="BFBFBF"/>
+                      </a:solidFill>
+                      <a:prstDash val="solid"/>
+                      <a:round/>
+                      <a:headEnd type="none" w="med" len="med"/>
+                      <a:tailEnd type="none" w="med" len="med"/>
+                    </a:lnT>
+                    <a:lnB w="9525" cap="flat" cmpd="sng" algn="ctr">
+                      <a:solidFill>
+                        <a:srgbClr val="BFBFBF"/>
+                      </a:solidFill>
+                      <a:prstDash val="solid"/>
+                      <a:round/>
+                      <a:headEnd type="none" w="med" len="med"/>
+                      <a:tailEnd type="none" w="med" len="med"/>
+                    </a:lnB>
+                  </a:tcPr>
+                </a:tc>
+                <a:tc>
+                  <a:txBody>
+                    <a:bodyPr/>
+                    <a:lstStyle/>
+                    <a:p>
+                      <a:pPr indent="0" marL="0">
+                        <a:buNone/>
+                      </a:pPr>
+                      <a:r>
+                        <a:rPr lang="en-US" sz="900" dirty="0">
+                          <a:solidFill>
+                            <a:srgbClr val="1A1A1A"/>
+                          </a:solidFill>
+                          <a:latin typeface="Arial" pitchFamily="34" charset="0"/>
+                          <a:ea typeface="Arial" pitchFamily="34" charset="-122"/>
+                          <a:cs typeface="Arial" pitchFamily="34" charset="-120"/>
+                        </a:rPr>
+                        <a:t>Fin drilling datum</a:t>
+                      </a:r>
+                      <a:endParaRPr lang="en-US" sz="900" dirty="0">
+                        <a:latin typeface="Arial" charset="0"/>
+                        <a:ea typeface="Arial" charset="0"/>
+                        <a:cs typeface="Arial" charset="0"/>
+                      </a:endParaRPr>
+                    </a:p>
+                  </a:txBody>
+                  <a:tcPr marL="54864" marR="54864" marT="54864" marB="54864" anchor="ctr">
+                    <a:lnL w="9525" cap="flat" cmpd="sng" algn="ctr">
+                      <a:solidFill>
+                        <a:srgbClr val="BFBFBF"/>
+                      </a:solidFill>
+                      <a:prstDash val="solid"/>
+                      <a:round/>
+                      <a:headEnd type="none" w="med" len="med"/>
+                      <a:tailEnd type="none" w="med" len="med"/>
+                    </a:lnL>
+                    <a:lnR w="9525" cap="flat" cmpd="sng" algn="ctr">
+                      <a:solidFill>
+                        <a:srgbClr val="BFBFBF"/>
+                      </a:solidFill>
+                      <a:prstDash val="solid"/>
+                      <a:round/>
+                      <a:headEnd type="none" w="med" len="med"/>
+                      <a:tailEnd type="none" w="med" len="med"/>
+                    </a:lnR>
+                    <a:lnT w="9525" cap="flat" cmpd="sng" algn="ctr">
+                      <a:solidFill>
+                        <a:srgbClr val="BFBFBF"/>
+                      </a:solidFill>
+                      <a:prstDash val="solid"/>
+                      <a:round/>
+                      <a:headEnd type="none" w="med" len="med"/>
+                      <a:tailEnd type="none" w="med" len="med"/>
+                    </a:lnT>
+                    <a:lnB w="9525" cap="flat" cmpd="sng" algn="ctr">
+                      <a:solidFill>
+                        <a:srgbClr val="BFBFBF"/>
+                      </a:solidFill>
+                      <a:prstDash val="solid"/>
+                      <a:round/>
+                      <a:headEnd type="none" w="med" len="med"/>
+                      <a:tailEnd type="none" w="med" len="med"/>
+                    </a:lnB>
+                  </a:tcPr>
+                </a:tc>
+                <a:tc>
+                  <a:txBody>
+                    <a:bodyPr/>
+                    <a:lstStyle/>
+                    <a:p>
+                      <a:pPr indent="0" marL="0">
+                        <a:buNone/>
+                      </a:pPr>
+                      <a:r>
+                        <a:rPr lang="en-US" sz="900" dirty="0">
+                          <a:solidFill>
+                            <a:srgbClr val="1A1A1A"/>
+                          </a:solidFill>
+                          <a:latin typeface="Arial" pitchFamily="34" charset="0"/>
+                          <a:ea typeface="Arial" pitchFamily="34" charset="-122"/>
+                          <a:cs typeface="Arial" pitchFamily="34" charset="-120"/>
+                        </a:rPr>
+                        <a:t>Edges locate the bottom-left hole; drilled, it is the zero for the other 4</a:t>
+                      </a:r>
+                      <a:endParaRPr lang="en-US" sz="900" dirty="0">
+                        <a:latin typeface="Arial" charset="0"/>
+                        <a:ea typeface="Arial" charset="0"/>
+                        <a:cs typeface="Arial" charset="0"/>
+                      </a:endParaRPr>
+                    </a:p>
+                  </a:txBody>
+                  <a:tcPr marL="54864" marR="54864" marT="54864" marB="54864" anchor="ctr">
+                    <a:lnL w="9525" cap="flat" cmpd="sng" algn="ctr">
+                      <a:solidFill>
+                        <a:srgbClr val="BFBFBF"/>
+                      </a:solidFill>
+                      <a:prstDash val="solid"/>
+                      <a:round/>
+                      <a:headEnd type="none" w="med" len="med"/>
+                      <a:tailEnd type="none" w="med" len="med"/>
+                    </a:lnL>
+                    <a:lnR w="9525" cap="flat" cmpd="sng" algn="ctr">
+                      <a:solidFill>
+                        <a:srgbClr val="BFBFBF"/>
+                      </a:solidFill>
+                      <a:prstDash val="solid"/>
+                      <a:round/>
+                      <a:headEnd type="none" w="med" len="med"/>
+                      <a:tailEnd type="none" w="med" len="med"/>
+                    </a:lnR>
+                    <a:lnT w="9525" cap="flat" cmpd="sng" algn="ctr">
+                      <a:solidFill>
+                        <a:srgbClr val="BFBFBF"/>
+                      </a:solidFill>
+                      <a:prstDash val="solid"/>
+                      <a:round/>
+                      <a:headEnd type="none" w="med" len="med"/>
+                      <a:tailEnd type="none" w="med" len="med"/>
+                    </a:lnT>
+                    <a:lnB w="9525" cap="flat" cmpd="sng" algn="ctr">
+                      <a:solidFill>
+                        <a:srgbClr val="BFBFBF"/>
+                      </a:solidFill>
+                      <a:prstDash val="solid"/>
+                      <a:round/>
+                      <a:headEnd type="none" w="med" len="med"/>
+                      <a:tailEnd type="none" w="med" len="med"/>
+                    </a:lnB>
+                  </a:tcPr>
+                </a:tc>
+                <a:tc>
+                  <a:txBody>
+                    <a:bodyPr/>
+                    <a:lstStyle/>
+                    <a:p>
+                      <a:pPr indent="0" marL="0">
+                        <a:buNone/>
+                      </a:pPr>
+                      <a:r>
+                        <a:rPr lang="en-US" sz="900" dirty="0">
                           <a:solidFill>
                             <a:srgbClr val="1A1A1A"/>
                           </a:solidFill>
@@ -13441,7 +14095,7 @@
                         </a:rPr>
                         <a:t>Pattern ±0.1, free of the ±0.5 sheared edges</a:t>
                       </a:r>
-                      <a:endParaRPr lang="en-US" sz="1050" dirty="0">
+                      <a:endParaRPr lang="en-US" sz="900" dirty="0">
                         <a:latin typeface="Arial" charset="0"/>
                         <a:ea typeface="Arial" charset="0"/>
                         <a:cs typeface="Arial" charset="0"/>
@@ -13500,8 +14154,8 @@
         </p:nvSpPr>
         <p:spPr>
           <a:xfrm>
-            <a:off x="6492240" y="5349240"/>
-            <a:ext cx="5150815" cy="868680"/>
+            <a:off x="6492240" y="5623560"/>
+            <a:ext cx="5150815" cy="731520"/>
           </a:xfrm>
           <a:prstGeom prst="rect">
             <a:avLst/>
@@ -13515,13 +14169,13 @@
           <a:p>
             <a:pPr algn="l" marL="254000" indent="-254000">
               <a:spcAft>
-                <a:spcPts val="400"/>
+                <a:spcPts val="200"/>
               </a:spcAft>
               <a:buSzPct val="100000"/>
               <a:buChar char="•"/>
             </a:pPr>
             <a:r>
-              <a:rPr lang="en-US" sz="1200" dirty="0">
+              <a:rPr lang="en-US" sz="1050" dirty="0">
                 <a:solidFill>
                   <a:srgbClr val="1A1A1A"/>
                 </a:solidFill>
@@ -13531,18 +14185,18 @@
               </a:rPr>
               <a:t>Printed holes come out small, so every printed fit carries an allowance; the drilled fin needs none</a:t>
             </a:r>
-            <a:endParaRPr lang="en-US" sz="1200" dirty="0"/>
+            <a:endParaRPr lang="en-US" sz="1050" dirty="0"/>
           </a:p>
           <a:p>
             <a:pPr algn="l" marL="254000" indent="-254000">
               <a:spcAft>
-                <a:spcPts val="400"/>
+                <a:spcPts val="200"/>
               </a:spcAft>
               <a:buSzPct val="100000"/>
               <a:buChar char="•"/>
             </a:pPr>
             <a:r>
-              <a:rPr lang="en-US" sz="1200" dirty="0">
+              <a:rPr lang="en-US" sz="1050" dirty="0">
                 <a:solidFill>
                   <a:srgbClr val="1A1A1A"/>
                 </a:solidFill>
@@ -13552,7 +14206,7 @@
               </a:rPr>
               <a:t>PETG on a Creality K1, 0.4 mm nozzle, 0.2 mm layers; loads along the layers, mating faces off supports</a:t>
             </a:r>
-            <a:endParaRPr lang="en-US" sz="1200" dirty="0"/>
+            <a:endParaRPr lang="en-US" sz="1050" dirty="0"/>
           </a:p>
         </p:txBody>
       </p:sp>

</xml_diff>